<commit_message>
Refactor flow to read Xetra-specific statuses and add video demo script
</commit_message>
<xml_diff>
--- a/presentations/ISAAI-Consolidated-Findings.pptx
+++ b/presentations/ISAAI-Consolidated-Findings.pptx
@@ -3134,7 +3134,7 @@
           </a:p>
           <a:p>
             <a:r>
-              <a:t>Generated on 2026-06-29 10:17:28</a:t>
+              <a:t>Generated on 2026-06-29 10:34:45</a:t>
             </a:r>
           </a:p>
         </p:txBody>
@@ -3225,7 +3225,7 @@
               </a:defRPr>
             </a:pPr>
             <a:r>
-              <a:t>• Completed (no violations): 20 (66.7%)</a:t>
+              <a:t>• Completed (no violations): 2 (6.7%)</a:t>
             </a:r>
           </a:p>
           <a:p>
@@ -3237,7 +3237,7 @@
               </a:defRPr>
             </a:pPr>
             <a:r>
-              <a:t>• Exception (escalation required): 10 (33.3%)</a:t>
+              <a:t>• Exception (escalation required): 28 (93.3%)</a:t>
             </a:r>
           </a:p>
           <a:p>
@@ -3266,7 +3266,7 @@
               </a:defRPr>
             </a:pPr>
             <a:r>
-              <a:t>  • Pass: 21  |  Violation: 9</a:t>
+              <a:t>  • Pass: 0  |  Violation: 0</a:t>
             </a:r>
           </a:p>
           <a:p>
@@ -3290,7 +3290,7 @@
               </a:defRPr>
             </a:pPr>
             <a:r>
-              <a:t>  • Pass: 26  |  Violation: 4</a:t>
+              <a:t>  • Pass: 0  |  Violation: 0</a:t>
             </a:r>
           </a:p>
         </p:txBody>
@@ -3566,6 +3566,36 @@
                     <a:lstStyle/>
                     <a:p>
                       <a:pPr algn="ctr">
+                        <a:defRPr sz="1000"/>
+                      </a:pPr>
+                      <a:r>
+                        <a:t>Pending</a:t>
+                      </a:r>
+                    </a:p>
+                  </a:txBody>
+                  <a:tcPr/>
+                </a:tc>
+                <a:tc>
+                  <a:txBody>
+                    <a:bodyPr/>
+                    <a:lstStyle/>
+                    <a:p>
+                      <a:pPr algn="ctr">
+                        <a:defRPr sz="1000"/>
+                      </a:pPr>
+                      <a:r>
+                        <a:t>Pending</a:t>
+                      </a:r>
+                    </a:p>
+                  </a:txBody>
+                  <a:tcPr/>
+                </a:tc>
+                <a:tc>
+                  <a:txBody>
+                    <a:bodyPr/>
+                    <a:lstStyle/>
+                    <a:p>
+                      <a:pPr algn="ctr">
                         <a:defRPr sz="1000" b="1">
                           <a:solidFill>
                             <a:srgbClr val="D9383A"/>
@@ -3573,7 +3603,988 @@
                         </a:defRPr>
                       </a:pPr>
                       <a:r>
-                        <a:t>Violation</a:t>
+                        <a:t>Exception</a:t>
+                      </a:r>
+                    </a:p>
+                  </a:txBody>
+                  <a:tcPr/>
+                </a:tc>
+                <a:tc>
+                  <a:txBody>
+                    <a:bodyPr/>
+                    <a:lstStyle/>
+                    <a:p>
+                      <a:pPr algn="ctr">
+                        <a:defRPr sz="1000" b="1">
+                          <a:solidFill>
+                            <a:srgbClr val="D9383A"/>
+                          </a:solidFill>
+                        </a:defRPr>
+                      </a:pPr>
+                      <a:r>
+                        <a:t>Yes</a:t>
+                      </a:r>
+                    </a:p>
+                  </a:txBody>
+                  <a:tcPr/>
+                </a:tc>
+              </a:tr>
+              <a:tr h="285750">
+                <a:tc>
+                  <a:txBody>
+                    <a:bodyPr/>
+                    <a:lstStyle/>
+                    <a:p>
+                      <a:pPr algn="ctr">
+                        <a:defRPr sz="1000"/>
+                      </a:pPr>
+                      <a:r>
+                        <a:t>24</a:t>
+                      </a:r>
+                    </a:p>
+                  </a:txBody>
+                  <a:tcPr/>
+                </a:tc>
+                <a:tc>
+                  <a:txBody>
+                    <a:bodyPr/>
+                    <a:lstStyle/>
+                    <a:p>
+                      <a:pPr algn="ctr">
+                        <a:defRPr sz="1000"/>
+                      </a:pPr>
+                      <a:r>
+                        <a:t>20260622</a:t>
+                      </a:r>
+                    </a:p>
+                  </a:txBody>
+                  <a:tcPr/>
+                </a:tc>
+                <a:tc>
+                  <a:txBody>
+                    <a:bodyPr/>
+                    <a:lstStyle/>
+                    <a:p>
+                      <a:pPr algn="ctr">
+                        <a:defRPr sz="1000"/>
+                      </a:pPr>
+                      <a:r>
+                        <a:t>Pending</a:t>
+                      </a:r>
+                    </a:p>
+                  </a:txBody>
+                  <a:tcPr/>
+                </a:tc>
+                <a:tc>
+                  <a:txBody>
+                    <a:bodyPr/>
+                    <a:lstStyle/>
+                    <a:p>
+                      <a:pPr algn="ctr">
+                        <a:defRPr sz="1000"/>
+                      </a:pPr>
+                      <a:r>
+                        <a:t>Pending</a:t>
+                      </a:r>
+                    </a:p>
+                  </a:txBody>
+                  <a:tcPr/>
+                </a:tc>
+                <a:tc>
+                  <a:txBody>
+                    <a:bodyPr/>
+                    <a:lstStyle/>
+                    <a:p>
+                      <a:pPr algn="ctr">
+                        <a:defRPr sz="1000" b="1">
+                          <a:solidFill>
+                            <a:srgbClr val="D9383A"/>
+                          </a:solidFill>
+                        </a:defRPr>
+                      </a:pPr>
+                      <a:r>
+                        <a:t>Exception</a:t>
+                      </a:r>
+                    </a:p>
+                  </a:txBody>
+                  <a:tcPr/>
+                </a:tc>
+                <a:tc>
+                  <a:txBody>
+                    <a:bodyPr/>
+                    <a:lstStyle/>
+                    <a:p>
+                      <a:pPr algn="ctr">
+                        <a:defRPr sz="1000" b="1">
+                          <a:solidFill>
+                            <a:srgbClr val="D9383A"/>
+                          </a:solidFill>
+                        </a:defRPr>
+                      </a:pPr>
+                      <a:r>
+                        <a:t>Yes</a:t>
+                      </a:r>
+                    </a:p>
+                  </a:txBody>
+                  <a:tcPr/>
+                </a:tc>
+              </a:tr>
+              <a:tr h="285750">
+                <a:tc>
+                  <a:txBody>
+                    <a:bodyPr/>
+                    <a:lstStyle/>
+                    <a:p>
+                      <a:pPr algn="ctr">
+                        <a:defRPr sz="1000"/>
+                      </a:pPr>
+                      <a:r>
+                        <a:t>25</a:t>
+                      </a:r>
+                    </a:p>
+                  </a:txBody>
+                  <a:tcPr/>
+                </a:tc>
+                <a:tc>
+                  <a:txBody>
+                    <a:bodyPr/>
+                    <a:lstStyle/>
+                    <a:p>
+                      <a:pPr algn="ctr">
+                        <a:defRPr sz="1000"/>
+                      </a:pPr>
+                      <a:r>
+                        <a:t>20260623</a:t>
+                      </a:r>
+                    </a:p>
+                  </a:txBody>
+                  <a:tcPr/>
+                </a:tc>
+                <a:tc>
+                  <a:txBody>
+                    <a:bodyPr/>
+                    <a:lstStyle/>
+                    <a:p>
+                      <a:pPr algn="ctr">
+                        <a:defRPr sz="1000"/>
+                      </a:pPr>
+                      <a:r>
+                        <a:t>Pending</a:t>
+                      </a:r>
+                    </a:p>
+                  </a:txBody>
+                  <a:tcPr/>
+                </a:tc>
+                <a:tc>
+                  <a:txBody>
+                    <a:bodyPr/>
+                    <a:lstStyle/>
+                    <a:p>
+                      <a:pPr algn="ctr">
+                        <a:defRPr sz="1000"/>
+                      </a:pPr>
+                      <a:r>
+                        <a:t>Pending</a:t>
+                      </a:r>
+                    </a:p>
+                  </a:txBody>
+                  <a:tcPr/>
+                </a:tc>
+                <a:tc>
+                  <a:txBody>
+                    <a:bodyPr/>
+                    <a:lstStyle/>
+                    <a:p>
+                      <a:pPr algn="ctr">
+                        <a:defRPr sz="1000" b="1">
+                          <a:solidFill>
+                            <a:srgbClr val="D9383A"/>
+                          </a:solidFill>
+                        </a:defRPr>
+                      </a:pPr>
+                      <a:r>
+                        <a:t>Exception</a:t>
+                      </a:r>
+                    </a:p>
+                  </a:txBody>
+                  <a:tcPr/>
+                </a:tc>
+                <a:tc>
+                  <a:txBody>
+                    <a:bodyPr/>
+                    <a:lstStyle/>
+                    <a:p>
+                      <a:pPr algn="ctr">
+                        <a:defRPr sz="1000" b="1">
+                          <a:solidFill>
+                            <a:srgbClr val="D9383A"/>
+                          </a:solidFill>
+                        </a:defRPr>
+                      </a:pPr>
+                      <a:r>
+                        <a:t>Yes</a:t>
+                      </a:r>
+                    </a:p>
+                  </a:txBody>
+                  <a:tcPr/>
+                </a:tc>
+              </a:tr>
+              <a:tr h="285750">
+                <a:tc>
+                  <a:txBody>
+                    <a:bodyPr/>
+                    <a:lstStyle/>
+                    <a:p>
+                      <a:pPr algn="ctr">
+                        <a:defRPr sz="1000"/>
+                      </a:pPr>
+                      <a:r>
+                        <a:t>26</a:t>
+                      </a:r>
+                    </a:p>
+                  </a:txBody>
+                  <a:tcPr/>
+                </a:tc>
+                <a:tc>
+                  <a:txBody>
+                    <a:bodyPr/>
+                    <a:lstStyle/>
+                    <a:p>
+                      <a:pPr algn="ctr">
+                        <a:defRPr sz="1000"/>
+                      </a:pPr>
+                      <a:r>
+                        <a:t>20260624</a:t>
+                      </a:r>
+                    </a:p>
+                  </a:txBody>
+                  <a:tcPr/>
+                </a:tc>
+                <a:tc>
+                  <a:txBody>
+                    <a:bodyPr/>
+                    <a:lstStyle/>
+                    <a:p>
+                      <a:pPr algn="ctr">
+                        <a:defRPr sz="1000"/>
+                      </a:pPr>
+                      <a:r>
+                        <a:t>Pending</a:t>
+                      </a:r>
+                    </a:p>
+                  </a:txBody>
+                  <a:tcPr/>
+                </a:tc>
+                <a:tc>
+                  <a:txBody>
+                    <a:bodyPr/>
+                    <a:lstStyle/>
+                    <a:p>
+                      <a:pPr algn="ctr">
+                        <a:defRPr sz="1000"/>
+                      </a:pPr>
+                      <a:r>
+                        <a:t>Pending</a:t>
+                      </a:r>
+                    </a:p>
+                  </a:txBody>
+                  <a:tcPr/>
+                </a:tc>
+                <a:tc>
+                  <a:txBody>
+                    <a:bodyPr/>
+                    <a:lstStyle/>
+                    <a:p>
+                      <a:pPr algn="ctr">
+                        <a:defRPr sz="1000" b="1">
+                          <a:solidFill>
+                            <a:srgbClr val="D9383A"/>
+                          </a:solidFill>
+                        </a:defRPr>
+                      </a:pPr>
+                      <a:r>
+                        <a:t>Exception</a:t>
+                      </a:r>
+                    </a:p>
+                  </a:txBody>
+                  <a:tcPr/>
+                </a:tc>
+                <a:tc>
+                  <a:txBody>
+                    <a:bodyPr/>
+                    <a:lstStyle/>
+                    <a:p>
+                      <a:pPr algn="ctr">
+                        <a:defRPr sz="1000" b="1">
+                          <a:solidFill>
+                            <a:srgbClr val="D9383A"/>
+                          </a:solidFill>
+                        </a:defRPr>
+                      </a:pPr>
+                      <a:r>
+                        <a:t>Yes</a:t>
+                      </a:r>
+                    </a:p>
+                  </a:txBody>
+                  <a:tcPr/>
+                </a:tc>
+              </a:tr>
+              <a:tr h="285750">
+                <a:tc>
+                  <a:txBody>
+                    <a:bodyPr/>
+                    <a:lstStyle/>
+                    <a:p>
+                      <a:pPr algn="ctr">
+                        <a:defRPr sz="1000"/>
+                      </a:pPr>
+                      <a:r>
+                        <a:t>27</a:t>
+                      </a:r>
+                    </a:p>
+                  </a:txBody>
+                  <a:tcPr/>
+                </a:tc>
+                <a:tc>
+                  <a:txBody>
+                    <a:bodyPr/>
+                    <a:lstStyle/>
+                    <a:p>
+                      <a:pPr algn="ctr">
+                        <a:defRPr sz="1000"/>
+                      </a:pPr>
+                      <a:r>
+                        <a:t>20260625</a:t>
+                      </a:r>
+                    </a:p>
+                  </a:txBody>
+                  <a:tcPr/>
+                </a:tc>
+                <a:tc>
+                  <a:txBody>
+                    <a:bodyPr/>
+                    <a:lstStyle/>
+                    <a:p>
+                      <a:pPr algn="ctr">
+                        <a:defRPr sz="1000"/>
+                      </a:pPr>
+                      <a:r>
+                        <a:t>Pending</a:t>
+                      </a:r>
+                    </a:p>
+                  </a:txBody>
+                  <a:tcPr/>
+                </a:tc>
+                <a:tc>
+                  <a:txBody>
+                    <a:bodyPr/>
+                    <a:lstStyle/>
+                    <a:p>
+                      <a:pPr algn="ctr">
+                        <a:defRPr sz="1000"/>
+                      </a:pPr>
+                      <a:r>
+                        <a:t>Pending</a:t>
+                      </a:r>
+                    </a:p>
+                  </a:txBody>
+                  <a:tcPr/>
+                </a:tc>
+                <a:tc>
+                  <a:txBody>
+                    <a:bodyPr/>
+                    <a:lstStyle/>
+                    <a:p>
+                      <a:pPr algn="ctr">
+                        <a:defRPr sz="1000" b="1">
+                          <a:solidFill>
+                            <a:srgbClr val="D9383A"/>
+                          </a:solidFill>
+                        </a:defRPr>
+                      </a:pPr>
+                      <a:r>
+                        <a:t>Exception</a:t>
+                      </a:r>
+                    </a:p>
+                  </a:txBody>
+                  <a:tcPr/>
+                </a:tc>
+                <a:tc>
+                  <a:txBody>
+                    <a:bodyPr/>
+                    <a:lstStyle/>
+                    <a:p>
+                      <a:pPr algn="ctr">
+                        <a:defRPr sz="1000" b="1">
+                          <a:solidFill>
+                            <a:srgbClr val="D9383A"/>
+                          </a:solidFill>
+                        </a:defRPr>
+                      </a:pPr>
+                      <a:r>
+                        <a:t>Yes</a:t>
+                      </a:r>
+                    </a:p>
+                  </a:txBody>
+                  <a:tcPr/>
+                </a:tc>
+              </a:tr>
+              <a:tr h="285750">
+                <a:tc>
+                  <a:txBody>
+                    <a:bodyPr/>
+                    <a:lstStyle/>
+                    <a:p>
+                      <a:pPr algn="ctr">
+                        <a:defRPr sz="1000"/>
+                      </a:pPr>
+                      <a:r>
+                        <a:t>28</a:t>
+                      </a:r>
+                    </a:p>
+                  </a:txBody>
+                  <a:tcPr/>
+                </a:tc>
+                <a:tc>
+                  <a:txBody>
+                    <a:bodyPr/>
+                    <a:lstStyle/>
+                    <a:p>
+                      <a:pPr algn="ctr">
+                        <a:defRPr sz="1000"/>
+                      </a:pPr>
+                      <a:r>
+                        <a:t>20260626</a:t>
+                      </a:r>
+                    </a:p>
+                  </a:txBody>
+                  <a:tcPr/>
+                </a:tc>
+                <a:tc>
+                  <a:txBody>
+                    <a:bodyPr/>
+                    <a:lstStyle/>
+                    <a:p>
+                      <a:pPr algn="ctr">
+                        <a:defRPr sz="1000"/>
+                      </a:pPr>
+                      <a:r>
+                        <a:t>Pending</a:t>
+                      </a:r>
+                    </a:p>
+                  </a:txBody>
+                  <a:tcPr/>
+                </a:tc>
+                <a:tc>
+                  <a:txBody>
+                    <a:bodyPr/>
+                    <a:lstStyle/>
+                    <a:p>
+                      <a:pPr algn="ctr">
+                        <a:defRPr sz="1000"/>
+                      </a:pPr>
+                      <a:r>
+                        <a:t>Pending</a:t>
+                      </a:r>
+                    </a:p>
+                  </a:txBody>
+                  <a:tcPr/>
+                </a:tc>
+                <a:tc>
+                  <a:txBody>
+                    <a:bodyPr/>
+                    <a:lstStyle/>
+                    <a:p>
+                      <a:pPr algn="ctr">
+                        <a:defRPr sz="1000" b="1">
+                          <a:solidFill>
+                            <a:srgbClr val="D9383A"/>
+                          </a:solidFill>
+                        </a:defRPr>
+                      </a:pPr>
+                      <a:r>
+                        <a:t>Exception</a:t>
+                      </a:r>
+                    </a:p>
+                  </a:txBody>
+                  <a:tcPr/>
+                </a:tc>
+                <a:tc>
+                  <a:txBody>
+                    <a:bodyPr/>
+                    <a:lstStyle/>
+                    <a:p>
+                      <a:pPr algn="ctr">
+                        <a:defRPr sz="1000" b="1">
+                          <a:solidFill>
+                            <a:srgbClr val="D9383A"/>
+                          </a:solidFill>
+                        </a:defRPr>
+                      </a:pPr>
+                      <a:r>
+                        <a:t>Yes</a:t>
+                      </a:r>
+                    </a:p>
+                  </a:txBody>
+                  <a:tcPr/>
+                </a:tc>
+              </a:tr>
+              <a:tr h="285750">
+                <a:tc>
+                  <a:txBody>
+                    <a:bodyPr/>
+                    <a:lstStyle/>
+                    <a:p>
+                      <a:pPr algn="ctr">
+                        <a:defRPr sz="1000"/>
+                      </a:pPr>
+                      <a:r>
+                        <a:t>29</a:t>
+                      </a:r>
+                    </a:p>
+                  </a:txBody>
+                  <a:tcPr/>
+                </a:tc>
+                <a:tc>
+                  <a:txBody>
+                    <a:bodyPr/>
+                    <a:lstStyle/>
+                    <a:p>
+                      <a:pPr algn="ctr">
+                        <a:defRPr sz="1000"/>
+                      </a:pPr>
+                      <a:r>
+                        <a:t>20260627</a:t>
+                      </a:r>
+                    </a:p>
+                  </a:txBody>
+                  <a:tcPr/>
+                </a:tc>
+                <a:tc>
+                  <a:txBody>
+                    <a:bodyPr/>
+                    <a:lstStyle/>
+                    <a:p>
+                      <a:pPr algn="ctr">
+                        <a:defRPr sz="1000"/>
+                      </a:pPr>
+                      <a:r>
+                        <a:t>Pending</a:t>
+                      </a:r>
+                    </a:p>
+                  </a:txBody>
+                  <a:tcPr/>
+                </a:tc>
+                <a:tc>
+                  <a:txBody>
+                    <a:bodyPr/>
+                    <a:lstStyle/>
+                    <a:p>
+                      <a:pPr algn="ctr">
+                        <a:defRPr sz="1000"/>
+                      </a:pPr>
+                      <a:r>
+                        <a:t>Pending</a:t>
+                      </a:r>
+                    </a:p>
+                  </a:txBody>
+                  <a:tcPr/>
+                </a:tc>
+                <a:tc>
+                  <a:txBody>
+                    <a:bodyPr/>
+                    <a:lstStyle/>
+                    <a:p>
+                      <a:pPr algn="ctr">
+                        <a:defRPr sz="1000" b="1">
+                          <a:solidFill>
+                            <a:srgbClr val="D9383A"/>
+                          </a:solidFill>
+                        </a:defRPr>
+                      </a:pPr>
+                      <a:r>
+                        <a:t>Exception</a:t>
+                      </a:r>
+                    </a:p>
+                  </a:txBody>
+                  <a:tcPr/>
+                </a:tc>
+                <a:tc>
+                  <a:txBody>
+                    <a:bodyPr/>
+                    <a:lstStyle/>
+                    <a:p>
+                      <a:pPr algn="ctr">
+                        <a:defRPr sz="1000" b="1">
+                          <a:solidFill>
+                            <a:srgbClr val="D9383A"/>
+                          </a:solidFill>
+                        </a:defRPr>
+                      </a:pPr>
+                      <a:r>
+                        <a:t>Yes</a:t>
+                      </a:r>
+                    </a:p>
+                  </a:txBody>
+                  <a:tcPr/>
+                </a:tc>
+              </a:tr>
+              <a:tr h="285750">
+                <a:tc>
+                  <a:txBody>
+                    <a:bodyPr/>
+                    <a:lstStyle/>
+                    <a:p>
+                      <a:pPr algn="ctr">
+                        <a:defRPr sz="1000"/>
+                      </a:pPr>
+                      <a:r>
+                        <a:t>3</a:t>
+                      </a:r>
+                    </a:p>
+                  </a:txBody>
+                  <a:tcPr/>
+                </a:tc>
+                <a:tc>
+                  <a:txBody>
+                    <a:bodyPr/>
+                    <a:lstStyle/>
+                    <a:p>
+                      <a:pPr algn="ctr">
+                        <a:defRPr sz="1000"/>
+                      </a:pPr>
+                      <a:r>
+                        <a:t>20260601</a:t>
+                      </a:r>
+                    </a:p>
+                  </a:txBody>
+                  <a:tcPr/>
+                </a:tc>
+                <a:tc>
+                  <a:txBody>
+                    <a:bodyPr/>
+                    <a:lstStyle/>
+                    <a:p>
+                      <a:pPr algn="ctr">
+                        <a:defRPr sz="1000"/>
+                      </a:pPr>
+                      <a:r>
+                        <a:t>Pending</a:t>
+                      </a:r>
+                    </a:p>
+                  </a:txBody>
+                  <a:tcPr/>
+                </a:tc>
+                <a:tc>
+                  <a:txBody>
+                    <a:bodyPr/>
+                    <a:lstStyle/>
+                    <a:p>
+                      <a:pPr algn="ctr">
+                        <a:defRPr sz="1000"/>
+                      </a:pPr>
+                      <a:r>
+                        <a:t>Pending</a:t>
+                      </a:r>
+                    </a:p>
+                  </a:txBody>
+                  <a:tcPr/>
+                </a:tc>
+                <a:tc>
+                  <a:txBody>
+                    <a:bodyPr/>
+                    <a:lstStyle/>
+                    <a:p>
+                      <a:pPr algn="ctr">
+                        <a:defRPr sz="1000" b="1">
+                          <a:solidFill>
+                            <a:srgbClr val="D9383A"/>
+                          </a:solidFill>
+                        </a:defRPr>
+                      </a:pPr>
+                      <a:r>
+                        <a:t>Exception</a:t>
+                      </a:r>
+                    </a:p>
+                  </a:txBody>
+                  <a:tcPr/>
+                </a:tc>
+                <a:tc>
+                  <a:txBody>
+                    <a:bodyPr/>
+                    <a:lstStyle/>
+                    <a:p>
+                      <a:pPr algn="ctr">
+                        <a:defRPr sz="1000" b="1">
+                          <a:solidFill>
+                            <a:srgbClr val="D9383A"/>
+                          </a:solidFill>
+                        </a:defRPr>
+                      </a:pPr>
+                      <a:r>
+                        <a:t>Yes</a:t>
+                      </a:r>
+                    </a:p>
+                  </a:txBody>
+                  <a:tcPr/>
+                </a:tc>
+              </a:tr>
+              <a:tr h="285750">
+                <a:tc>
+                  <a:txBody>
+                    <a:bodyPr/>
+                    <a:lstStyle/>
+                    <a:p>
+                      <a:pPr algn="ctr">
+                        <a:defRPr sz="1000"/>
+                      </a:pPr>
+                      <a:r>
+                        <a:t>30</a:t>
+                      </a:r>
+                    </a:p>
+                  </a:txBody>
+                  <a:tcPr/>
+                </a:tc>
+                <a:tc>
+                  <a:txBody>
+                    <a:bodyPr/>
+                    <a:lstStyle/>
+                    <a:p>
+                      <a:pPr algn="ctr">
+                        <a:defRPr sz="1000"/>
+                      </a:pPr>
+                      <a:r>
+                        <a:t>20260628</a:t>
+                      </a:r>
+                    </a:p>
+                  </a:txBody>
+                  <a:tcPr/>
+                </a:tc>
+                <a:tc>
+                  <a:txBody>
+                    <a:bodyPr/>
+                    <a:lstStyle/>
+                    <a:p>
+                      <a:pPr algn="ctr">
+                        <a:defRPr sz="1000"/>
+                      </a:pPr>
+                      <a:r>
+                        <a:t>Pending</a:t>
+                      </a:r>
+                    </a:p>
+                  </a:txBody>
+                  <a:tcPr/>
+                </a:tc>
+                <a:tc>
+                  <a:txBody>
+                    <a:bodyPr/>
+                    <a:lstStyle/>
+                    <a:p>
+                      <a:pPr algn="ctr">
+                        <a:defRPr sz="1000"/>
+                      </a:pPr>
+                      <a:r>
+                        <a:t>Pending</a:t>
+                      </a:r>
+                    </a:p>
+                  </a:txBody>
+                  <a:tcPr/>
+                </a:tc>
+                <a:tc>
+                  <a:txBody>
+                    <a:bodyPr/>
+                    <a:lstStyle/>
+                    <a:p>
+                      <a:pPr algn="ctr">
+                        <a:defRPr sz="1000" b="1">
+                          <a:solidFill>
+                            <a:srgbClr val="D9383A"/>
+                          </a:solidFill>
+                        </a:defRPr>
+                      </a:pPr>
+                      <a:r>
+                        <a:t>Exception</a:t>
+                      </a:r>
+                    </a:p>
+                  </a:txBody>
+                  <a:tcPr/>
+                </a:tc>
+                <a:tc>
+                  <a:txBody>
+                    <a:bodyPr/>
+                    <a:lstStyle/>
+                    <a:p>
+                      <a:pPr algn="ctr">
+                        <a:defRPr sz="1000" b="1">
+                          <a:solidFill>
+                            <a:srgbClr val="D9383A"/>
+                          </a:solidFill>
+                        </a:defRPr>
+                      </a:pPr>
+                      <a:r>
+                        <a:t>Yes</a:t>
+                      </a:r>
+                    </a:p>
+                  </a:txBody>
+                  <a:tcPr/>
+                </a:tc>
+              </a:tr>
+              <a:tr h="285750">
+                <a:tc>
+                  <a:txBody>
+                    <a:bodyPr/>
+                    <a:lstStyle/>
+                    <a:p>
+                      <a:pPr algn="ctr">
+                        <a:defRPr sz="1000"/>
+                      </a:pPr>
+                      <a:r>
+                        <a:t>4</a:t>
+                      </a:r>
+                    </a:p>
+                  </a:txBody>
+                  <a:tcPr/>
+                </a:tc>
+                <a:tc>
+                  <a:txBody>
+                    <a:bodyPr/>
+                    <a:lstStyle/>
+                    <a:p>
+                      <a:pPr algn="ctr">
+                        <a:defRPr sz="1000"/>
+                      </a:pPr>
+                      <a:r>
+                        <a:t>20260602</a:t>
+                      </a:r>
+                    </a:p>
+                  </a:txBody>
+                  <a:tcPr/>
+                </a:tc>
+                <a:tc>
+                  <a:txBody>
+                    <a:bodyPr/>
+                    <a:lstStyle/>
+                    <a:p>
+                      <a:pPr algn="ctr">
+                        <a:defRPr sz="1000"/>
+                      </a:pPr>
+                      <a:r>
+                        <a:t>Pending</a:t>
+                      </a:r>
+                    </a:p>
+                  </a:txBody>
+                  <a:tcPr/>
+                </a:tc>
+                <a:tc>
+                  <a:txBody>
+                    <a:bodyPr/>
+                    <a:lstStyle/>
+                    <a:p>
+                      <a:pPr algn="ctr">
+                        <a:defRPr sz="1000"/>
+                      </a:pPr>
+                      <a:r>
+                        <a:t>Pending</a:t>
+                      </a:r>
+                    </a:p>
+                  </a:txBody>
+                  <a:tcPr/>
+                </a:tc>
+                <a:tc>
+                  <a:txBody>
+                    <a:bodyPr/>
+                    <a:lstStyle/>
+                    <a:p>
+                      <a:pPr algn="ctr">
+                        <a:defRPr sz="1000" b="1">
+                          <a:solidFill>
+                            <a:srgbClr val="D9383A"/>
+                          </a:solidFill>
+                        </a:defRPr>
+                      </a:pPr>
+                      <a:r>
+                        <a:t>Exception</a:t>
+                      </a:r>
+                    </a:p>
+                  </a:txBody>
+                  <a:tcPr/>
+                </a:tc>
+                <a:tc>
+                  <a:txBody>
+                    <a:bodyPr/>
+                    <a:lstStyle/>
+                    <a:p>
+                      <a:pPr algn="ctr">
+                        <a:defRPr sz="1000" b="1">
+                          <a:solidFill>
+                            <a:srgbClr val="D9383A"/>
+                          </a:solidFill>
+                        </a:defRPr>
+                      </a:pPr>
+                      <a:r>
+                        <a:t>Yes</a:t>
+                      </a:r>
+                    </a:p>
+                  </a:txBody>
+                  <a:tcPr/>
+                </a:tc>
+              </a:tr>
+              <a:tr h="285750">
+                <a:tc>
+                  <a:txBody>
+                    <a:bodyPr/>
+                    <a:lstStyle/>
+                    <a:p>
+                      <a:pPr algn="ctr">
+                        <a:defRPr sz="1000"/>
+                      </a:pPr>
+                      <a:r>
+                        <a:t>5</a:t>
+                      </a:r>
+                    </a:p>
+                  </a:txBody>
+                  <a:tcPr/>
+                </a:tc>
+                <a:tc>
+                  <a:txBody>
+                    <a:bodyPr/>
+                    <a:lstStyle/>
+                    <a:p>
+                      <a:pPr algn="ctr">
+                        <a:defRPr sz="1000"/>
+                      </a:pPr>
+                      <a:r>
+                        <a:t>20260603</a:t>
+                      </a:r>
+                    </a:p>
+                  </a:txBody>
+                  <a:tcPr/>
+                </a:tc>
+                <a:tc>
+                  <a:txBody>
+                    <a:bodyPr/>
+                    <a:lstStyle/>
+                    <a:p>
+                      <a:pPr algn="ctr">
+                        <a:defRPr sz="1000"/>
+                      </a:pPr>
+                      <a:r>
+                        <a:t>Pending</a:t>
+                      </a:r>
+                    </a:p>
+                  </a:txBody>
+                  <a:tcPr/>
+                </a:tc>
+                <a:tc>
+                  <a:txBody>
+                    <a:bodyPr/>
+                    <a:lstStyle/>
+                    <a:p>
+                      <a:pPr algn="ctr">
+                        <a:defRPr sz="1000"/>
+                      </a:pPr>
+                      <a:r>
+                        <a:t>Pending</a:t>
                       </a:r>
                     </a:p>
                   </a:txBody>
@@ -3592,7 +4603,88 @@
                         </a:defRPr>
                       </a:pPr>
                       <a:r>
-                        <a:t>Pass</a:t>
+                        <a:t>Completed</a:t>
+                      </a:r>
+                    </a:p>
+                  </a:txBody>
+                  <a:tcPr/>
+                </a:tc>
+                <a:tc>
+                  <a:txBody>
+                    <a:bodyPr/>
+                    <a:lstStyle/>
+                    <a:p>
+                      <a:pPr algn="ctr">
+                        <a:defRPr sz="1000">
+                          <a:solidFill>
+                            <a:srgbClr val="2E7D32"/>
+                          </a:solidFill>
+                        </a:defRPr>
+                      </a:pPr>
+                      <a:r>
+                        <a:t>No</a:t>
+                      </a:r>
+                    </a:p>
+                  </a:txBody>
+                  <a:tcPr/>
+                </a:tc>
+              </a:tr>
+              <a:tr h="285750">
+                <a:tc>
+                  <a:txBody>
+                    <a:bodyPr/>
+                    <a:lstStyle/>
+                    <a:p>
+                      <a:pPr algn="ctr">
+                        <a:defRPr sz="1000"/>
+                      </a:pPr>
+                      <a:r>
+                        <a:t>6</a:t>
+                      </a:r>
+                    </a:p>
+                  </a:txBody>
+                  <a:tcPr/>
+                </a:tc>
+                <a:tc>
+                  <a:txBody>
+                    <a:bodyPr/>
+                    <a:lstStyle/>
+                    <a:p>
+                      <a:pPr algn="ctr">
+                        <a:defRPr sz="1000"/>
+                      </a:pPr>
+                      <a:r>
+                        <a:t>20260604</a:t>
+                      </a:r>
+                    </a:p>
+                  </a:txBody>
+                  <a:tcPr/>
+                </a:tc>
+                <a:tc>
+                  <a:txBody>
+                    <a:bodyPr/>
+                    <a:lstStyle/>
+                    <a:p>
+                      <a:pPr algn="ctr">
+                        <a:defRPr sz="1000"/>
+                      </a:pPr>
+                      <a:r>
+                        <a:t>Pending</a:t>
+                      </a:r>
+                    </a:p>
+                  </a:txBody>
+                  <a:tcPr/>
+                </a:tc>
+                <a:tc>
+                  <a:txBody>
+                    <a:bodyPr/>
+                    <a:lstStyle/>
+                    <a:p>
+                      <a:pPr algn="ctr">
+                        <a:defRPr sz="1000"/>
+                      </a:pPr>
+                      <a:r>
+                        <a:t>Pending</a:t>
                       </a:r>
                     </a:p>
                   </a:txBody>
@@ -3647,149 +4739,52 @@
                         <a:defRPr sz="1000"/>
                       </a:pPr>
                       <a:r>
-                        <a:t>24</a:t>
-                      </a:r>
-                    </a:p>
-                  </a:txBody>
-                  <a:tcPr/>
-                </a:tc>
-                <a:tc>
-                  <a:txBody>
-                    <a:bodyPr/>
-                    <a:lstStyle/>
-                    <a:p>
-                      <a:pPr algn="ctr">
-                        <a:defRPr sz="1000"/>
-                      </a:pPr>
-                      <a:r>
-                        <a:t>20260622</a:t>
-                      </a:r>
-                    </a:p>
-                  </a:txBody>
-                  <a:tcPr/>
-                </a:tc>
-                <a:tc>
-                  <a:txBody>
-                    <a:bodyPr/>
-                    <a:lstStyle/>
-                    <a:p>
-                      <a:pPr algn="ctr">
-                        <a:defRPr sz="1000">
-                          <a:solidFill>
-                            <a:srgbClr val="2E7D32"/>
-                          </a:solidFill>
-                        </a:defRPr>
-                      </a:pPr>
-                      <a:r>
-                        <a:t>Pass</a:t>
-                      </a:r>
-                    </a:p>
-                  </a:txBody>
-                  <a:tcPr/>
-                </a:tc>
-                <a:tc>
-                  <a:txBody>
-                    <a:bodyPr/>
-                    <a:lstStyle/>
-                    <a:p>
-                      <a:pPr algn="ctr">
-                        <a:defRPr sz="1000">
-                          <a:solidFill>
-                            <a:srgbClr val="2E7D32"/>
-                          </a:solidFill>
-                        </a:defRPr>
-                      </a:pPr>
-                      <a:r>
-                        <a:t>Pass</a:t>
-                      </a:r>
-                    </a:p>
-                  </a:txBody>
-                  <a:tcPr/>
-                </a:tc>
-                <a:tc>
-                  <a:txBody>
-                    <a:bodyPr/>
-                    <a:lstStyle/>
-                    <a:p>
-                      <a:pPr algn="ctr">
-                        <a:defRPr sz="1000">
-                          <a:solidFill>
-                            <a:srgbClr val="2E7D32"/>
-                          </a:solidFill>
-                        </a:defRPr>
-                      </a:pPr>
-                      <a:r>
-                        <a:t>Completed</a:t>
-                      </a:r>
-                    </a:p>
-                  </a:txBody>
-                  <a:tcPr/>
-                </a:tc>
-                <a:tc>
-                  <a:txBody>
-                    <a:bodyPr/>
-                    <a:lstStyle/>
-                    <a:p>
-                      <a:pPr algn="ctr">
-                        <a:defRPr sz="1000">
-                          <a:solidFill>
-                            <a:srgbClr val="2E7D32"/>
-                          </a:solidFill>
-                        </a:defRPr>
-                      </a:pPr>
-                      <a:r>
-                        <a:t>No</a:t>
-                      </a:r>
-                    </a:p>
-                  </a:txBody>
-                  <a:tcPr/>
-                </a:tc>
-              </a:tr>
-              <a:tr h="285750">
-                <a:tc>
-                  <a:txBody>
-                    <a:bodyPr/>
-                    <a:lstStyle/>
-                    <a:p>
-                      <a:pPr algn="ctr">
-                        <a:defRPr sz="1000"/>
-                      </a:pPr>
-                      <a:r>
-                        <a:t>25</a:t>
-                      </a:r>
-                    </a:p>
-                  </a:txBody>
-                  <a:tcPr/>
-                </a:tc>
-                <a:tc>
-                  <a:txBody>
-                    <a:bodyPr/>
-                    <a:lstStyle/>
-                    <a:p>
-                      <a:pPr algn="ctr">
-                        <a:defRPr sz="1000"/>
-                      </a:pPr>
-                      <a:r>
-                        <a:t>20260623</a:t>
-                      </a:r>
-                    </a:p>
-                  </a:txBody>
-                  <a:tcPr/>
-                </a:tc>
-                <a:tc>
-                  <a:txBody>
-                    <a:bodyPr/>
-                    <a:lstStyle/>
-                    <a:p>
-                      <a:pPr algn="ctr">
-                        <a:defRPr sz="1000">
-                          <a:solidFill>
-                            <a:srgbClr val="2E7D32"/>
-                          </a:solidFill>
-                        </a:defRPr>
-                      </a:pPr>
-                      <a:r>
-                        <a:t>Pass</a:t>
+                        <a:t>7</a:t>
+                      </a:r>
+                    </a:p>
+                  </a:txBody>
+                  <a:tcPr/>
+                </a:tc>
+                <a:tc>
+                  <a:txBody>
+                    <a:bodyPr/>
+                    <a:lstStyle/>
+                    <a:p>
+                      <a:pPr algn="ctr">
+                        <a:defRPr sz="1000"/>
+                      </a:pPr>
+                      <a:r>
+                        <a:t>20260605</a:t>
+                      </a:r>
+                    </a:p>
+                  </a:txBody>
+                  <a:tcPr/>
+                </a:tc>
+                <a:tc>
+                  <a:txBody>
+                    <a:bodyPr/>
+                    <a:lstStyle/>
+                    <a:p>
+                      <a:pPr algn="ctr">
+                        <a:defRPr sz="1000"/>
+                      </a:pPr>
+                      <a:r>
+                        <a:t>Pending</a:t>
+                      </a:r>
+                    </a:p>
+                  </a:txBody>
+                  <a:tcPr/>
+                </a:tc>
+                <a:tc>
+                  <a:txBody>
+                    <a:bodyPr/>
+                    <a:lstStyle/>
+                    <a:p>
+                      <a:pPr algn="ctr">
+                        <a:defRPr sz="1000"/>
+                      </a:pPr>
+                      <a:r>
+                        <a:t>Pending</a:t>
                       </a:r>
                     </a:p>
                   </a:txBody>
@@ -3808,7 +4803,7 @@
                         </a:defRPr>
                       </a:pPr>
                       <a:r>
-                        <a:t>Violation</a:t>
+                        <a:t>Exception</a:t>
                       </a:r>
                     </a:p>
                   </a:txBody>
@@ -3827,7 +4822,69 @@
                         </a:defRPr>
                       </a:pPr>
                       <a:r>
-                        <a:t>Exception</a:t>
+                        <a:t>Yes</a:t>
+                      </a:r>
+                    </a:p>
+                  </a:txBody>
+                  <a:tcPr/>
+                </a:tc>
+              </a:tr>
+              <a:tr h="285750">
+                <a:tc>
+                  <a:txBody>
+                    <a:bodyPr/>
+                    <a:lstStyle/>
+                    <a:p>
+                      <a:pPr algn="ctr">
+                        <a:defRPr sz="1000"/>
+                      </a:pPr>
+                      <a:r>
+                        <a:t>8</a:t>
+                      </a:r>
+                    </a:p>
+                  </a:txBody>
+                  <a:tcPr/>
+                </a:tc>
+                <a:tc>
+                  <a:txBody>
+                    <a:bodyPr/>
+                    <a:lstStyle/>
+                    <a:p>
+                      <a:pPr algn="ctr">
+                        <a:defRPr sz="1000"/>
+                      </a:pPr>
+                      <a:r>
+                        <a:t>20260606</a:t>
+                      </a:r>
+                    </a:p>
+                  </a:txBody>
+                  <a:tcPr/>
+                </a:tc>
+                <a:tc>
+                  <a:txBody>
+                    <a:bodyPr/>
+                    <a:lstStyle/>
+                    <a:p>
+                      <a:pPr algn="ctr">
+                        <a:defRPr sz="1000"/>
+                      </a:pPr>
+                      <a:r>
+                        <a:t>Pending</a:t>
+                      </a:r>
+                    </a:p>
+                  </a:txBody>
+                  <a:tcPr/>
+                </a:tc>
+                <a:tc>
+                  <a:txBody>
+                    <a:bodyPr/>
+                    <a:lstStyle/>
+                    <a:p>
+                      <a:pPr algn="ctr">
+                        <a:defRPr sz="1000"/>
+                      </a:pPr>
+                      <a:r>
+                        <a:t>Pending</a:t>
                       </a:r>
                     </a:p>
                   </a:txBody>
@@ -3846,903 +4903,7 @@
                         </a:defRPr>
                       </a:pPr>
                       <a:r>
-                        <a:t>Yes</a:t>
-                      </a:r>
-                    </a:p>
-                  </a:txBody>
-                  <a:tcPr/>
-                </a:tc>
-              </a:tr>
-              <a:tr h="285750">
-                <a:tc>
-                  <a:txBody>
-                    <a:bodyPr/>
-                    <a:lstStyle/>
-                    <a:p>
-                      <a:pPr algn="ctr">
-                        <a:defRPr sz="1000"/>
-                      </a:pPr>
-                      <a:r>
-                        <a:t>26</a:t>
-                      </a:r>
-                    </a:p>
-                  </a:txBody>
-                  <a:tcPr/>
-                </a:tc>
-                <a:tc>
-                  <a:txBody>
-                    <a:bodyPr/>
-                    <a:lstStyle/>
-                    <a:p>
-                      <a:pPr algn="ctr">
-                        <a:defRPr sz="1000"/>
-                      </a:pPr>
-                      <a:r>
-                        <a:t>20260624</a:t>
-                      </a:r>
-                    </a:p>
-                  </a:txBody>
-                  <a:tcPr/>
-                </a:tc>
-                <a:tc>
-                  <a:txBody>
-                    <a:bodyPr/>
-                    <a:lstStyle/>
-                    <a:p>
-                      <a:pPr algn="ctr">
-                        <a:defRPr sz="1000">
-                          <a:solidFill>
-                            <a:srgbClr val="2E7D32"/>
-                          </a:solidFill>
-                        </a:defRPr>
-                      </a:pPr>
-                      <a:r>
-                        <a:t>Pass</a:t>
-                      </a:r>
-                    </a:p>
-                  </a:txBody>
-                  <a:tcPr/>
-                </a:tc>
-                <a:tc>
-                  <a:txBody>
-                    <a:bodyPr/>
-                    <a:lstStyle/>
-                    <a:p>
-                      <a:pPr algn="ctr">
-                        <a:defRPr sz="1000">
-                          <a:solidFill>
-                            <a:srgbClr val="2E7D32"/>
-                          </a:solidFill>
-                        </a:defRPr>
-                      </a:pPr>
-                      <a:r>
-                        <a:t>Pass</a:t>
-                      </a:r>
-                    </a:p>
-                  </a:txBody>
-                  <a:tcPr/>
-                </a:tc>
-                <a:tc>
-                  <a:txBody>
-                    <a:bodyPr/>
-                    <a:lstStyle/>
-                    <a:p>
-                      <a:pPr algn="ctr">
-                        <a:defRPr sz="1000">
-                          <a:solidFill>
-                            <a:srgbClr val="2E7D32"/>
-                          </a:solidFill>
-                        </a:defRPr>
-                      </a:pPr>
-                      <a:r>
-                        <a:t>Completed</a:t>
-                      </a:r>
-                    </a:p>
-                  </a:txBody>
-                  <a:tcPr/>
-                </a:tc>
-                <a:tc>
-                  <a:txBody>
-                    <a:bodyPr/>
-                    <a:lstStyle/>
-                    <a:p>
-                      <a:pPr algn="ctr">
-                        <a:defRPr sz="1000">
-                          <a:solidFill>
-                            <a:srgbClr val="2E7D32"/>
-                          </a:solidFill>
-                        </a:defRPr>
-                      </a:pPr>
-                      <a:r>
-                        <a:t>No</a:t>
-                      </a:r>
-                    </a:p>
-                  </a:txBody>
-                  <a:tcPr/>
-                </a:tc>
-              </a:tr>
-              <a:tr h="285750">
-                <a:tc>
-                  <a:txBody>
-                    <a:bodyPr/>
-                    <a:lstStyle/>
-                    <a:p>
-                      <a:pPr algn="ctr">
-                        <a:defRPr sz="1000"/>
-                      </a:pPr>
-                      <a:r>
-                        <a:t>27</a:t>
-                      </a:r>
-                    </a:p>
-                  </a:txBody>
-                  <a:tcPr/>
-                </a:tc>
-                <a:tc>
-                  <a:txBody>
-                    <a:bodyPr/>
-                    <a:lstStyle/>
-                    <a:p>
-                      <a:pPr algn="ctr">
-                        <a:defRPr sz="1000"/>
-                      </a:pPr>
-                      <a:r>
-                        <a:t>20260625</a:t>
-                      </a:r>
-                    </a:p>
-                  </a:txBody>
-                  <a:tcPr/>
-                </a:tc>
-                <a:tc>
-                  <a:txBody>
-                    <a:bodyPr/>
-                    <a:lstStyle/>
-                    <a:p>
-                      <a:pPr algn="ctr">
-                        <a:defRPr sz="1000">
-                          <a:solidFill>
-                            <a:srgbClr val="2E7D32"/>
-                          </a:solidFill>
-                        </a:defRPr>
-                      </a:pPr>
-                      <a:r>
-                        <a:t>Pass</a:t>
-                      </a:r>
-                    </a:p>
-                  </a:txBody>
-                  <a:tcPr/>
-                </a:tc>
-                <a:tc>
-                  <a:txBody>
-                    <a:bodyPr/>
-                    <a:lstStyle/>
-                    <a:p>
-                      <a:pPr algn="ctr">
-                        <a:defRPr sz="1000">
-                          <a:solidFill>
-                            <a:srgbClr val="2E7D32"/>
-                          </a:solidFill>
-                        </a:defRPr>
-                      </a:pPr>
-                      <a:r>
-                        <a:t>Pass</a:t>
-                      </a:r>
-                    </a:p>
-                  </a:txBody>
-                  <a:tcPr/>
-                </a:tc>
-                <a:tc>
-                  <a:txBody>
-                    <a:bodyPr/>
-                    <a:lstStyle/>
-                    <a:p>
-                      <a:pPr algn="ctr">
-                        <a:defRPr sz="1000">
-                          <a:solidFill>
-                            <a:srgbClr val="2E7D32"/>
-                          </a:solidFill>
-                        </a:defRPr>
-                      </a:pPr>
-                      <a:r>
-                        <a:t>Completed</a:t>
-                      </a:r>
-                    </a:p>
-                  </a:txBody>
-                  <a:tcPr/>
-                </a:tc>
-                <a:tc>
-                  <a:txBody>
-                    <a:bodyPr/>
-                    <a:lstStyle/>
-                    <a:p>
-                      <a:pPr algn="ctr">
-                        <a:defRPr sz="1000">
-                          <a:solidFill>
-                            <a:srgbClr val="2E7D32"/>
-                          </a:solidFill>
-                        </a:defRPr>
-                      </a:pPr>
-                      <a:r>
-                        <a:t>No</a:t>
-                      </a:r>
-                    </a:p>
-                  </a:txBody>
-                  <a:tcPr/>
-                </a:tc>
-              </a:tr>
-              <a:tr h="285750">
-                <a:tc>
-                  <a:txBody>
-                    <a:bodyPr/>
-                    <a:lstStyle/>
-                    <a:p>
-                      <a:pPr algn="ctr">
-                        <a:defRPr sz="1000"/>
-                      </a:pPr>
-                      <a:r>
-                        <a:t>28</a:t>
-                      </a:r>
-                    </a:p>
-                  </a:txBody>
-                  <a:tcPr/>
-                </a:tc>
-                <a:tc>
-                  <a:txBody>
-                    <a:bodyPr/>
-                    <a:lstStyle/>
-                    <a:p>
-                      <a:pPr algn="ctr">
-                        <a:defRPr sz="1000"/>
-                      </a:pPr>
-                      <a:r>
-                        <a:t>20260626</a:t>
-                      </a:r>
-                    </a:p>
-                  </a:txBody>
-                  <a:tcPr/>
-                </a:tc>
-                <a:tc>
-                  <a:txBody>
-                    <a:bodyPr/>
-                    <a:lstStyle/>
-                    <a:p>
-                      <a:pPr algn="ctr">
-                        <a:defRPr sz="1000">
-                          <a:solidFill>
-                            <a:srgbClr val="2E7D32"/>
-                          </a:solidFill>
-                        </a:defRPr>
-                      </a:pPr>
-                      <a:r>
-                        <a:t>Pass</a:t>
-                      </a:r>
-                    </a:p>
-                  </a:txBody>
-                  <a:tcPr/>
-                </a:tc>
-                <a:tc>
-                  <a:txBody>
-                    <a:bodyPr/>
-                    <a:lstStyle/>
-                    <a:p>
-                      <a:pPr algn="ctr">
-                        <a:defRPr sz="1000">
-                          <a:solidFill>
-                            <a:srgbClr val="2E7D32"/>
-                          </a:solidFill>
-                        </a:defRPr>
-                      </a:pPr>
-                      <a:r>
-                        <a:t>Pass</a:t>
-                      </a:r>
-                    </a:p>
-                  </a:txBody>
-                  <a:tcPr/>
-                </a:tc>
-                <a:tc>
-                  <a:txBody>
-                    <a:bodyPr/>
-                    <a:lstStyle/>
-                    <a:p>
-                      <a:pPr algn="ctr">
-                        <a:defRPr sz="1000">
-                          <a:solidFill>
-                            <a:srgbClr val="2E7D32"/>
-                          </a:solidFill>
-                        </a:defRPr>
-                      </a:pPr>
-                      <a:r>
-                        <a:t>Completed</a:t>
-                      </a:r>
-                    </a:p>
-                  </a:txBody>
-                  <a:tcPr/>
-                </a:tc>
-                <a:tc>
-                  <a:txBody>
-                    <a:bodyPr/>
-                    <a:lstStyle/>
-                    <a:p>
-                      <a:pPr algn="ctr">
-                        <a:defRPr sz="1000">
-                          <a:solidFill>
-                            <a:srgbClr val="2E7D32"/>
-                          </a:solidFill>
-                        </a:defRPr>
-                      </a:pPr>
-                      <a:r>
-                        <a:t>No</a:t>
-                      </a:r>
-                    </a:p>
-                  </a:txBody>
-                  <a:tcPr/>
-                </a:tc>
-              </a:tr>
-              <a:tr h="285750">
-                <a:tc>
-                  <a:txBody>
-                    <a:bodyPr/>
-                    <a:lstStyle/>
-                    <a:p>
-                      <a:pPr algn="ctr">
-                        <a:defRPr sz="1000"/>
-                      </a:pPr>
-                      <a:r>
-                        <a:t>29</a:t>
-                      </a:r>
-                    </a:p>
-                  </a:txBody>
-                  <a:tcPr/>
-                </a:tc>
-                <a:tc>
-                  <a:txBody>
-                    <a:bodyPr/>
-                    <a:lstStyle/>
-                    <a:p>
-                      <a:pPr algn="ctr">
-                        <a:defRPr sz="1000"/>
-                      </a:pPr>
-                      <a:r>
-                        <a:t>20260627</a:t>
-                      </a:r>
-                    </a:p>
-                  </a:txBody>
-                  <a:tcPr/>
-                </a:tc>
-                <a:tc>
-                  <a:txBody>
-                    <a:bodyPr/>
-                    <a:lstStyle/>
-                    <a:p>
-                      <a:pPr algn="ctr">
-                        <a:defRPr sz="1000">
-                          <a:solidFill>
-                            <a:srgbClr val="2E7D32"/>
-                          </a:solidFill>
-                        </a:defRPr>
-                      </a:pPr>
-                      <a:r>
-                        <a:t>Pass</a:t>
-                      </a:r>
-                    </a:p>
-                  </a:txBody>
-                  <a:tcPr/>
-                </a:tc>
-                <a:tc>
-                  <a:txBody>
-                    <a:bodyPr/>
-                    <a:lstStyle/>
-                    <a:p>
-                      <a:pPr algn="ctr">
-                        <a:defRPr sz="1000">
-                          <a:solidFill>
-                            <a:srgbClr val="2E7D32"/>
-                          </a:solidFill>
-                        </a:defRPr>
-                      </a:pPr>
-                      <a:r>
-                        <a:t>Pass</a:t>
-                      </a:r>
-                    </a:p>
-                  </a:txBody>
-                  <a:tcPr/>
-                </a:tc>
-                <a:tc>
-                  <a:txBody>
-                    <a:bodyPr/>
-                    <a:lstStyle/>
-                    <a:p>
-                      <a:pPr algn="ctr">
-                        <a:defRPr sz="1000">
-                          <a:solidFill>
-                            <a:srgbClr val="2E7D32"/>
-                          </a:solidFill>
-                        </a:defRPr>
-                      </a:pPr>
-                      <a:r>
-                        <a:t>Completed</a:t>
-                      </a:r>
-                    </a:p>
-                  </a:txBody>
-                  <a:tcPr/>
-                </a:tc>
-                <a:tc>
-                  <a:txBody>
-                    <a:bodyPr/>
-                    <a:lstStyle/>
-                    <a:p>
-                      <a:pPr algn="ctr">
-                        <a:defRPr sz="1000">
-                          <a:solidFill>
-                            <a:srgbClr val="2E7D32"/>
-                          </a:solidFill>
-                        </a:defRPr>
-                      </a:pPr>
-                      <a:r>
-                        <a:t>No</a:t>
-                      </a:r>
-                    </a:p>
-                  </a:txBody>
-                  <a:tcPr/>
-                </a:tc>
-              </a:tr>
-              <a:tr h="285750">
-                <a:tc>
-                  <a:txBody>
-                    <a:bodyPr/>
-                    <a:lstStyle/>
-                    <a:p>
-                      <a:pPr algn="ctr">
-                        <a:defRPr sz="1000"/>
-                      </a:pPr>
-                      <a:r>
-                        <a:t>3</a:t>
-                      </a:r>
-                    </a:p>
-                  </a:txBody>
-                  <a:tcPr/>
-                </a:tc>
-                <a:tc>
-                  <a:txBody>
-                    <a:bodyPr/>
-                    <a:lstStyle/>
-                    <a:p>
-                      <a:pPr algn="ctr">
-                        <a:defRPr sz="1000"/>
-                      </a:pPr>
-                      <a:r>
-                        <a:t>20260601</a:t>
-                      </a:r>
-                    </a:p>
-                  </a:txBody>
-                  <a:tcPr/>
-                </a:tc>
-                <a:tc>
-                  <a:txBody>
-                    <a:bodyPr/>
-                    <a:lstStyle/>
-                    <a:p>
-                      <a:pPr algn="ctr">
-                        <a:defRPr sz="1000">
-                          <a:solidFill>
-                            <a:srgbClr val="2E7D32"/>
-                          </a:solidFill>
-                        </a:defRPr>
-                      </a:pPr>
-                      <a:r>
-                        <a:t>Pass</a:t>
-                      </a:r>
-                    </a:p>
-                  </a:txBody>
-                  <a:tcPr/>
-                </a:tc>
-                <a:tc>
-                  <a:txBody>
-                    <a:bodyPr/>
-                    <a:lstStyle/>
-                    <a:p>
-                      <a:pPr algn="ctr">
-                        <a:defRPr sz="1000">
-                          <a:solidFill>
-                            <a:srgbClr val="2E7D32"/>
-                          </a:solidFill>
-                        </a:defRPr>
-                      </a:pPr>
-                      <a:r>
-                        <a:t>Pass</a:t>
-                      </a:r>
-                    </a:p>
-                  </a:txBody>
-                  <a:tcPr/>
-                </a:tc>
-                <a:tc>
-                  <a:txBody>
-                    <a:bodyPr/>
-                    <a:lstStyle/>
-                    <a:p>
-                      <a:pPr algn="ctr">
-                        <a:defRPr sz="1000">
-                          <a:solidFill>
-                            <a:srgbClr val="2E7D32"/>
-                          </a:solidFill>
-                        </a:defRPr>
-                      </a:pPr>
-                      <a:r>
-                        <a:t>Completed</a:t>
-                      </a:r>
-                    </a:p>
-                  </a:txBody>
-                  <a:tcPr/>
-                </a:tc>
-                <a:tc>
-                  <a:txBody>
-                    <a:bodyPr/>
-                    <a:lstStyle/>
-                    <a:p>
-                      <a:pPr algn="ctr">
-                        <a:defRPr sz="1000">
-                          <a:solidFill>
-                            <a:srgbClr val="2E7D32"/>
-                          </a:solidFill>
-                        </a:defRPr>
-                      </a:pPr>
-                      <a:r>
-                        <a:t>No</a:t>
-                      </a:r>
-                    </a:p>
-                  </a:txBody>
-                  <a:tcPr/>
-                </a:tc>
-              </a:tr>
-              <a:tr h="285750">
-                <a:tc>
-                  <a:txBody>
-                    <a:bodyPr/>
-                    <a:lstStyle/>
-                    <a:p>
-                      <a:pPr algn="ctr">
-                        <a:defRPr sz="1000"/>
-                      </a:pPr>
-                      <a:r>
-                        <a:t>30</a:t>
-                      </a:r>
-                    </a:p>
-                  </a:txBody>
-                  <a:tcPr/>
-                </a:tc>
-                <a:tc>
-                  <a:txBody>
-                    <a:bodyPr/>
-                    <a:lstStyle/>
-                    <a:p>
-                      <a:pPr algn="ctr">
-                        <a:defRPr sz="1000"/>
-                      </a:pPr>
-                      <a:r>
-                        <a:t>20260628</a:t>
-                      </a:r>
-                    </a:p>
-                  </a:txBody>
-                  <a:tcPr/>
-                </a:tc>
-                <a:tc>
-                  <a:txBody>
-                    <a:bodyPr/>
-                    <a:lstStyle/>
-                    <a:p>
-                      <a:pPr algn="ctr">
-                        <a:defRPr sz="1000">
-                          <a:solidFill>
-                            <a:srgbClr val="2E7D32"/>
-                          </a:solidFill>
-                        </a:defRPr>
-                      </a:pPr>
-                      <a:r>
-                        <a:t>Pass</a:t>
-                      </a:r>
-                    </a:p>
-                  </a:txBody>
-                  <a:tcPr/>
-                </a:tc>
-                <a:tc>
-                  <a:txBody>
-                    <a:bodyPr/>
-                    <a:lstStyle/>
-                    <a:p>
-                      <a:pPr algn="ctr">
-                        <a:defRPr sz="1000">
-                          <a:solidFill>
-                            <a:srgbClr val="2E7D32"/>
-                          </a:solidFill>
-                        </a:defRPr>
-                      </a:pPr>
-                      <a:r>
-                        <a:t>Pass</a:t>
-                      </a:r>
-                    </a:p>
-                  </a:txBody>
-                  <a:tcPr/>
-                </a:tc>
-                <a:tc>
-                  <a:txBody>
-                    <a:bodyPr/>
-                    <a:lstStyle/>
-                    <a:p>
-                      <a:pPr algn="ctr">
-                        <a:defRPr sz="1000">
-                          <a:solidFill>
-                            <a:srgbClr val="2E7D32"/>
-                          </a:solidFill>
-                        </a:defRPr>
-                      </a:pPr>
-                      <a:r>
-                        <a:t>Completed</a:t>
-                      </a:r>
-                    </a:p>
-                  </a:txBody>
-                  <a:tcPr/>
-                </a:tc>
-                <a:tc>
-                  <a:txBody>
-                    <a:bodyPr/>
-                    <a:lstStyle/>
-                    <a:p>
-                      <a:pPr algn="ctr">
-                        <a:defRPr sz="1000">
-                          <a:solidFill>
-                            <a:srgbClr val="2E7D32"/>
-                          </a:solidFill>
-                        </a:defRPr>
-                      </a:pPr>
-                      <a:r>
-                        <a:t>No</a:t>
-                      </a:r>
-                    </a:p>
-                  </a:txBody>
-                  <a:tcPr/>
-                </a:tc>
-              </a:tr>
-              <a:tr h="285750">
-                <a:tc>
-                  <a:txBody>
-                    <a:bodyPr/>
-                    <a:lstStyle/>
-                    <a:p>
-                      <a:pPr algn="ctr">
-                        <a:defRPr sz="1000"/>
-                      </a:pPr>
-                      <a:r>
-                        <a:t>4</a:t>
-                      </a:r>
-                    </a:p>
-                  </a:txBody>
-                  <a:tcPr/>
-                </a:tc>
-                <a:tc>
-                  <a:txBody>
-                    <a:bodyPr/>
-                    <a:lstStyle/>
-                    <a:p>
-                      <a:pPr algn="ctr">
-                        <a:defRPr sz="1000"/>
-                      </a:pPr>
-                      <a:r>
-                        <a:t>20260602</a:t>
-                      </a:r>
-                    </a:p>
-                  </a:txBody>
-                  <a:tcPr/>
-                </a:tc>
-                <a:tc>
-                  <a:txBody>
-                    <a:bodyPr/>
-                    <a:lstStyle/>
-                    <a:p>
-                      <a:pPr algn="ctr">
-                        <a:defRPr sz="1000">
-                          <a:solidFill>
-                            <a:srgbClr val="2E7D32"/>
-                          </a:solidFill>
-                        </a:defRPr>
-                      </a:pPr>
-                      <a:r>
-                        <a:t>Pass</a:t>
-                      </a:r>
-                    </a:p>
-                  </a:txBody>
-                  <a:tcPr/>
-                </a:tc>
-                <a:tc>
-                  <a:txBody>
-                    <a:bodyPr/>
-                    <a:lstStyle/>
-                    <a:p>
-                      <a:pPr algn="ctr">
-                        <a:defRPr sz="1000">
-                          <a:solidFill>
-                            <a:srgbClr val="2E7D32"/>
-                          </a:solidFill>
-                        </a:defRPr>
-                      </a:pPr>
-                      <a:r>
-                        <a:t>Pass</a:t>
-                      </a:r>
-                    </a:p>
-                  </a:txBody>
-                  <a:tcPr/>
-                </a:tc>
-                <a:tc>
-                  <a:txBody>
-                    <a:bodyPr/>
-                    <a:lstStyle/>
-                    <a:p>
-                      <a:pPr algn="ctr">
-                        <a:defRPr sz="1000">
-                          <a:solidFill>
-                            <a:srgbClr val="2E7D32"/>
-                          </a:solidFill>
-                        </a:defRPr>
-                      </a:pPr>
-                      <a:r>
-                        <a:t>Completed</a:t>
-                      </a:r>
-                    </a:p>
-                  </a:txBody>
-                  <a:tcPr/>
-                </a:tc>
-                <a:tc>
-                  <a:txBody>
-                    <a:bodyPr/>
-                    <a:lstStyle/>
-                    <a:p>
-                      <a:pPr algn="ctr">
-                        <a:defRPr sz="1000">
-                          <a:solidFill>
-                            <a:srgbClr val="2E7D32"/>
-                          </a:solidFill>
-                        </a:defRPr>
-                      </a:pPr>
-                      <a:r>
-                        <a:t>No</a:t>
-                      </a:r>
-                    </a:p>
-                  </a:txBody>
-                  <a:tcPr/>
-                </a:tc>
-              </a:tr>
-              <a:tr h="285750">
-                <a:tc>
-                  <a:txBody>
-                    <a:bodyPr/>
-                    <a:lstStyle/>
-                    <a:p>
-                      <a:pPr algn="ctr">
-                        <a:defRPr sz="1000"/>
-                      </a:pPr>
-                      <a:r>
-                        <a:t>5</a:t>
-                      </a:r>
-                    </a:p>
-                  </a:txBody>
-                  <a:tcPr/>
-                </a:tc>
-                <a:tc>
-                  <a:txBody>
-                    <a:bodyPr/>
-                    <a:lstStyle/>
-                    <a:p>
-                      <a:pPr algn="ctr">
-                        <a:defRPr sz="1000"/>
-                      </a:pPr>
-                      <a:r>
-                        <a:t>20260603</a:t>
-                      </a:r>
-                    </a:p>
-                  </a:txBody>
-                  <a:tcPr/>
-                </a:tc>
-                <a:tc>
-                  <a:txBody>
-                    <a:bodyPr/>
-                    <a:lstStyle/>
-                    <a:p>
-                      <a:pPr algn="ctr">
-                        <a:defRPr sz="1000">
-                          <a:solidFill>
-                            <a:srgbClr val="2E7D32"/>
-                          </a:solidFill>
-                        </a:defRPr>
-                      </a:pPr>
-                      <a:r>
-                        <a:t>Pass</a:t>
-                      </a:r>
-                    </a:p>
-                  </a:txBody>
-                  <a:tcPr/>
-                </a:tc>
-                <a:tc>
-                  <a:txBody>
-                    <a:bodyPr/>
-                    <a:lstStyle/>
-                    <a:p>
-                      <a:pPr algn="ctr">
-                        <a:defRPr sz="1000">
-                          <a:solidFill>
-                            <a:srgbClr val="2E7D32"/>
-                          </a:solidFill>
-                        </a:defRPr>
-                      </a:pPr>
-                      <a:r>
-                        <a:t>Pass</a:t>
-                      </a:r>
-                    </a:p>
-                  </a:txBody>
-                  <a:tcPr/>
-                </a:tc>
-                <a:tc>
-                  <a:txBody>
-                    <a:bodyPr/>
-                    <a:lstStyle/>
-                    <a:p>
-                      <a:pPr algn="ctr">
-                        <a:defRPr sz="1000">
-                          <a:solidFill>
-                            <a:srgbClr val="2E7D32"/>
-                          </a:solidFill>
-                        </a:defRPr>
-                      </a:pPr>
-                      <a:r>
-                        <a:t>Completed</a:t>
-                      </a:r>
-                    </a:p>
-                  </a:txBody>
-                  <a:tcPr/>
-                </a:tc>
-                <a:tc>
-                  <a:txBody>
-                    <a:bodyPr/>
-                    <a:lstStyle/>
-                    <a:p>
-                      <a:pPr algn="ctr">
-                        <a:defRPr sz="1000">
-                          <a:solidFill>
-                            <a:srgbClr val="2E7D32"/>
-                          </a:solidFill>
-                        </a:defRPr>
-                      </a:pPr>
-                      <a:r>
-                        <a:t>No</a:t>
-                      </a:r>
-                    </a:p>
-                  </a:txBody>
-                  <a:tcPr/>
-                </a:tc>
-              </a:tr>
-              <a:tr h="285750">
-                <a:tc>
-                  <a:txBody>
-                    <a:bodyPr/>
-                    <a:lstStyle/>
-                    <a:p>
-                      <a:pPr algn="ctr">
-                        <a:defRPr sz="1000"/>
-                      </a:pPr>
-                      <a:r>
-                        <a:t>6</a:t>
-                      </a:r>
-                    </a:p>
-                  </a:txBody>
-                  <a:tcPr/>
-                </a:tc>
-                <a:tc>
-                  <a:txBody>
-                    <a:bodyPr/>
-                    <a:lstStyle/>
-                    <a:p>
-                      <a:pPr algn="ctr">
-                        <a:defRPr sz="1000"/>
-                      </a:pPr>
-                      <a:r>
-                        <a:t>20260604</a:t>
+                        <a:t>Exception</a:t>
                       </a:r>
                     </a:p>
                   </a:txBody>
@@ -4761,63 +4922,6 @@
                         </a:defRPr>
                       </a:pPr>
                       <a:r>
-                        <a:t>Violation</a:t>
-                      </a:r>
-                    </a:p>
-                  </a:txBody>
-                  <a:tcPr/>
-                </a:tc>
-                <a:tc>
-                  <a:txBody>
-                    <a:bodyPr/>
-                    <a:lstStyle/>
-                    <a:p>
-                      <a:pPr algn="ctr">
-                        <a:defRPr sz="1000">
-                          <a:solidFill>
-                            <a:srgbClr val="2E7D32"/>
-                          </a:solidFill>
-                        </a:defRPr>
-                      </a:pPr>
-                      <a:r>
-                        <a:t>Pass</a:t>
-                      </a:r>
-                    </a:p>
-                  </a:txBody>
-                  <a:tcPr/>
-                </a:tc>
-                <a:tc>
-                  <a:txBody>
-                    <a:bodyPr/>
-                    <a:lstStyle/>
-                    <a:p>
-                      <a:pPr algn="ctr">
-                        <a:defRPr sz="1000" b="1">
-                          <a:solidFill>
-                            <a:srgbClr val="D9383A"/>
-                          </a:solidFill>
-                        </a:defRPr>
-                      </a:pPr>
-                      <a:r>
-                        <a:t>Exception</a:t>
-                      </a:r>
-                    </a:p>
-                  </a:txBody>
-                  <a:tcPr/>
-                </a:tc>
-                <a:tc>
-                  <a:txBody>
-                    <a:bodyPr/>
-                    <a:lstStyle/>
-                    <a:p>
-                      <a:pPr algn="ctr">
-                        <a:defRPr sz="1000" b="1">
-                          <a:solidFill>
-                            <a:srgbClr val="D9383A"/>
-                          </a:solidFill>
-                        </a:defRPr>
-                      </a:pPr>
-                      <a:r>
                         <a:t>Yes</a:t>
                       </a:r>
                     </a:p>
@@ -4835,222 +4939,6 @@
                         <a:defRPr sz="1000"/>
                       </a:pPr>
                       <a:r>
-                        <a:t>7</a:t>
-                      </a:r>
-                    </a:p>
-                  </a:txBody>
-                  <a:tcPr/>
-                </a:tc>
-                <a:tc>
-                  <a:txBody>
-                    <a:bodyPr/>
-                    <a:lstStyle/>
-                    <a:p>
-                      <a:pPr algn="ctr">
-                        <a:defRPr sz="1000"/>
-                      </a:pPr>
-                      <a:r>
-                        <a:t>20260605</a:t>
-                      </a:r>
-                    </a:p>
-                  </a:txBody>
-                  <a:tcPr/>
-                </a:tc>
-                <a:tc>
-                  <a:txBody>
-                    <a:bodyPr/>
-                    <a:lstStyle/>
-                    <a:p>
-                      <a:pPr algn="ctr">
-                        <a:defRPr sz="1000" b="1">
-                          <a:solidFill>
-                            <a:srgbClr val="D9383A"/>
-                          </a:solidFill>
-                        </a:defRPr>
-                      </a:pPr>
-                      <a:r>
-                        <a:t>Violation</a:t>
-                      </a:r>
-                    </a:p>
-                  </a:txBody>
-                  <a:tcPr/>
-                </a:tc>
-                <a:tc>
-                  <a:txBody>
-                    <a:bodyPr/>
-                    <a:lstStyle/>
-                    <a:p>
-                      <a:pPr algn="ctr">
-                        <a:defRPr sz="1000" b="1">
-                          <a:solidFill>
-                            <a:srgbClr val="D9383A"/>
-                          </a:solidFill>
-                        </a:defRPr>
-                      </a:pPr>
-                      <a:r>
-                        <a:t>Violation</a:t>
-                      </a:r>
-                    </a:p>
-                  </a:txBody>
-                  <a:tcPr/>
-                </a:tc>
-                <a:tc>
-                  <a:txBody>
-                    <a:bodyPr/>
-                    <a:lstStyle/>
-                    <a:p>
-                      <a:pPr algn="ctr">
-                        <a:defRPr sz="1000" b="1">
-                          <a:solidFill>
-                            <a:srgbClr val="D9383A"/>
-                          </a:solidFill>
-                        </a:defRPr>
-                      </a:pPr>
-                      <a:r>
-                        <a:t>Exception</a:t>
-                      </a:r>
-                    </a:p>
-                  </a:txBody>
-                  <a:tcPr/>
-                </a:tc>
-                <a:tc>
-                  <a:txBody>
-                    <a:bodyPr/>
-                    <a:lstStyle/>
-                    <a:p>
-                      <a:pPr algn="ctr">
-                        <a:defRPr sz="1000" b="1">
-                          <a:solidFill>
-                            <a:srgbClr val="D9383A"/>
-                          </a:solidFill>
-                        </a:defRPr>
-                      </a:pPr>
-                      <a:r>
-                        <a:t>Yes</a:t>
-                      </a:r>
-                    </a:p>
-                  </a:txBody>
-                  <a:tcPr/>
-                </a:tc>
-              </a:tr>
-              <a:tr h="285750">
-                <a:tc>
-                  <a:txBody>
-                    <a:bodyPr/>
-                    <a:lstStyle/>
-                    <a:p>
-                      <a:pPr algn="ctr">
-                        <a:defRPr sz="1000"/>
-                      </a:pPr>
-                      <a:r>
-                        <a:t>8</a:t>
-                      </a:r>
-                    </a:p>
-                  </a:txBody>
-                  <a:tcPr/>
-                </a:tc>
-                <a:tc>
-                  <a:txBody>
-                    <a:bodyPr/>
-                    <a:lstStyle/>
-                    <a:p>
-                      <a:pPr algn="ctr">
-                        <a:defRPr sz="1000"/>
-                      </a:pPr>
-                      <a:r>
-                        <a:t>20260606</a:t>
-                      </a:r>
-                    </a:p>
-                  </a:txBody>
-                  <a:tcPr/>
-                </a:tc>
-                <a:tc>
-                  <a:txBody>
-                    <a:bodyPr/>
-                    <a:lstStyle/>
-                    <a:p>
-                      <a:pPr algn="ctr">
-                        <a:defRPr sz="1000" b="1">
-                          <a:solidFill>
-                            <a:srgbClr val="D9383A"/>
-                          </a:solidFill>
-                        </a:defRPr>
-                      </a:pPr>
-                      <a:r>
-                        <a:t>Violation</a:t>
-                      </a:r>
-                    </a:p>
-                  </a:txBody>
-                  <a:tcPr/>
-                </a:tc>
-                <a:tc>
-                  <a:txBody>
-                    <a:bodyPr/>
-                    <a:lstStyle/>
-                    <a:p>
-                      <a:pPr algn="ctr">
-                        <a:defRPr sz="1000" b="1">
-                          <a:solidFill>
-                            <a:srgbClr val="D9383A"/>
-                          </a:solidFill>
-                        </a:defRPr>
-                      </a:pPr>
-                      <a:r>
-                        <a:t>Violation</a:t>
-                      </a:r>
-                    </a:p>
-                  </a:txBody>
-                  <a:tcPr/>
-                </a:tc>
-                <a:tc>
-                  <a:txBody>
-                    <a:bodyPr/>
-                    <a:lstStyle/>
-                    <a:p>
-                      <a:pPr algn="ctr">
-                        <a:defRPr sz="1000" b="1">
-                          <a:solidFill>
-                            <a:srgbClr val="D9383A"/>
-                          </a:solidFill>
-                        </a:defRPr>
-                      </a:pPr>
-                      <a:r>
-                        <a:t>Exception</a:t>
-                      </a:r>
-                    </a:p>
-                  </a:txBody>
-                  <a:tcPr/>
-                </a:tc>
-                <a:tc>
-                  <a:txBody>
-                    <a:bodyPr/>
-                    <a:lstStyle/>
-                    <a:p>
-                      <a:pPr algn="ctr">
-                        <a:defRPr sz="1000" b="1">
-                          <a:solidFill>
-                            <a:srgbClr val="D9383A"/>
-                          </a:solidFill>
-                        </a:defRPr>
-                      </a:pPr>
-                      <a:r>
-                        <a:t>Yes</a:t>
-                      </a:r>
-                    </a:p>
-                  </a:txBody>
-                  <a:tcPr/>
-                </a:tc>
-              </a:tr>
-              <a:tr h="285750">
-                <a:tc>
-                  <a:txBody>
-                    <a:bodyPr/>
-                    <a:lstStyle/>
-                    <a:p>
-                      <a:pPr algn="ctr">
-                        <a:defRPr sz="1000"/>
-                      </a:pPr>
-                      <a:r>
                         <a:t>9</a:t>
                       </a:r>
                     </a:p>
@@ -5078,33 +4966,25 @@
                     <a:lstStyle/>
                     <a:p>
                       <a:pPr algn="ctr">
-                        <a:defRPr sz="1000" b="1">
-                          <a:solidFill>
-                            <a:srgbClr val="D9383A"/>
-                          </a:solidFill>
-                        </a:defRPr>
-                      </a:pPr>
-                      <a:r>
-                        <a:t>Violation</a:t>
-                      </a:r>
-                    </a:p>
-                  </a:txBody>
-                  <a:tcPr/>
-                </a:tc>
-                <a:tc>
-                  <a:txBody>
-                    <a:bodyPr/>
-                    <a:lstStyle/>
-                    <a:p>
-                      <a:pPr algn="ctr">
-                        <a:defRPr sz="1000">
-                          <a:solidFill>
-                            <a:srgbClr val="2E7D32"/>
-                          </a:solidFill>
-                        </a:defRPr>
-                      </a:pPr>
-                      <a:r>
-                        <a:t>Pass</a:t>
+                        <a:defRPr sz="1000"/>
+                      </a:pPr>
+                      <a:r>
+                        <a:t>Pending</a:t>
+                      </a:r>
+                    </a:p>
+                  </a:txBody>
+                  <a:tcPr/>
+                </a:tc>
+                <a:tc>
+                  <a:txBody>
+                    <a:bodyPr/>
+                    <a:lstStyle/>
+                    <a:p>
+                      <a:pPr algn="ctr">
+                        <a:defRPr sz="1000"/>
+                      </a:pPr>
+                      <a:r>
+                        <a:t>Pending</a:t>
                       </a:r>
                     </a:p>
                   </a:txBody>
@@ -5194,7 +5074,7 @@
               </a:defRPr>
             </a:pPr>
             <a:r>
-              <a:t>Exception Deep-Dive (10 runs)</a:t>
+              <a:t>Exception Deep-Dive (28 runs)</a:t>
             </a:r>
           </a:p>
         </p:txBody>
@@ -5229,24 +5109,12 @@
             <a:pPr>
               <a:defRPr sz="1400">
                 <a:solidFill>
-                  <a:srgbClr val="D9383A"/>
+                  <a:srgbClr val="2E7D32"/>
                 </a:solidFill>
               </a:defRPr>
             </a:pPr>
             <a:r>
-              <a:t>  Report A (DayViol=V): Violation</a:t>
-            </a:r>
-          </a:p>
-          <a:p>
-            <a:pPr>
-              <a:defRPr sz="1200">
-                <a:solidFill>
-                  <a:srgbClr val="D9383A"/>
-                </a:solidFill>
-              </a:defRPr>
-            </a:pPr>
-            <a:r>
-              <a:t>    ⚠ Threshold2: 16 (limit: 50)</a:t>
+              <a:t>  Report A (DayViol=?): ?</a:t>
             </a:r>
           </a:p>
           <a:p>
@@ -5258,7 +5126,7 @@
               </a:defRPr>
             </a:pPr>
             <a:r>
-              <a:t>  Report B (MonthViol=N): Pass</a:t>
+              <a:t>  Report B (MonthViol=?): ?</a:t>
             </a:r>
           </a:p>
           <a:p>
@@ -5270,31 +5138,19 @@
               </a:defRPr>
             </a:pPr>
             <a:r>
-              <a:t>Run 12 (20260610):</a:t>
+              <a:t>Run 10 (20260608):</a:t>
             </a:r>
           </a:p>
           <a:p>
             <a:pPr>
               <a:defRPr sz="1400">
                 <a:solidFill>
-                  <a:srgbClr val="D9383A"/>
+                  <a:srgbClr val="2E7D32"/>
                 </a:solidFill>
               </a:defRPr>
             </a:pPr>
             <a:r>
-              <a:t>  Report A (DayViol=V): Violation</a:t>
-            </a:r>
-          </a:p>
-          <a:p>
-            <a:pPr>
-              <a:defRPr sz="1200">
-                <a:solidFill>
-                  <a:srgbClr val="D9383A"/>
-                </a:solidFill>
-              </a:defRPr>
-            </a:pPr>
-            <a:r>
-              <a:t>    ⚠ Threshold4: 20 (limit: 50)</a:t>
+              <a:t>  Report A (DayViol=?): ?</a:t>
             </a:r>
           </a:p>
           <a:p>
@@ -5306,7 +5162,7 @@
               </a:defRPr>
             </a:pPr>
             <a:r>
-              <a:t>  Report B (MonthViol=N): Pass</a:t>
+              <a:t>  Report B (MonthViol=?): ?</a:t>
             </a:r>
           </a:p>
           <a:p>
@@ -5318,31 +5174,19 @@
               </a:defRPr>
             </a:pPr>
             <a:r>
-              <a:t>Run 14 (20260612):</a:t>
+              <a:t>Run 11 (20260609):</a:t>
             </a:r>
           </a:p>
           <a:p>
             <a:pPr>
               <a:defRPr sz="1400">
                 <a:solidFill>
-                  <a:srgbClr val="D9383A"/>
+                  <a:srgbClr val="2E7D32"/>
                 </a:solidFill>
               </a:defRPr>
             </a:pPr>
             <a:r>
-              <a:t>  Report A (DayViol=V): Violation</a:t>
-            </a:r>
-          </a:p>
-          <a:p>
-            <a:pPr>
-              <a:defRPr sz="1200">
-                <a:solidFill>
-                  <a:srgbClr val="D9383A"/>
-                </a:solidFill>
-              </a:defRPr>
-            </a:pPr>
-            <a:r>
-              <a:t>    ⚠ Threshold1: 33 (limit: 50)</a:t>
+              <a:t>  Report A (DayViol=?): ?</a:t>
             </a:r>
           </a:p>
           <a:p>
@@ -5354,7 +5198,7 @@
               </a:defRPr>
             </a:pPr>
             <a:r>
-              <a:t>  Report B (MonthViol=V): Pass</a:t>
+              <a:t>  Report B (MonthViol=?): ?</a:t>
             </a:r>
           </a:p>
           <a:p>
@@ -5366,55 +5210,31 @@
               </a:defRPr>
             </a:pPr>
             <a:r>
-              <a:t>Run 21 (20260619):</a:t>
+              <a:t>Run 12 (20260610):</a:t>
             </a:r>
           </a:p>
           <a:p>
             <a:pPr>
               <a:defRPr sz="1400">
                 <a:solidFill>
-                  <a:srgbClr val="D9383A"/>
+                  <a:srgbClr val="2E7D32"/>
                 </a:solidFill>
               </a:defRPr>
             </a:pPr>
             <a:r>
-              <a:t>  Report A (DayViol=V): Violation</a:t>
-            </a:r>
-          </a:p>
-          <a:p>
-            <a:pPr>
-              <a:defRPr sz="1200">
-                <a:solidFill>
-                  <a:srgbClr val="D9383A"/>
-                </a:solidFill>
-              </a:defRPr>
-            </a:pPr>
-            <a:r>
-              <a:t>    ⚠ Threshold3: 16 (limit: 50)</a:t>
+              <a:t>  Report A (DayViol=?): ?</a:t>
             </a:r>
           </a:p>
           <a:p>
             <a:pPr>
               <a:defRPr sz="1400">
                 <a:solidFill>
-                  <a:srgbClr val="D9383A"/>
+                  <a:srgbClr val="2E7D32"/>
                 </a:solidFill>
               </a:defRPr>
             </a:pPr>
             <a:r>
-              <a:t>  Report B (MonthViol=V): Violation</a:t>
-            </a:r>
-          </a:p>
-          <a:p>
-            <a:pPr>
-              <a:defRPr sz="1200">
-                <a:solidFill>
-                  <a:srgbClr val="D9383A"/>
-                </a:solidFill>
-              </a:defRPr>
-            </a:pPr>
-            <a:r>
-              <a:t>    ⚠ Threshold2: 37 (limit: 50)</a:t>
+              <a:t>  Report B (MonthViol=?): ?</a:t>
             </a:r>
           </a:p>
           <a:p>
@@ -5426,31 +5246,19 @@
               </a:defRPr>
             </a:pPr>
             <a:r>
-              <a:t>Run 23 (20260621):</a:t>
+              <a:t>Run 13 (20260611):</a:t>
             </a:r>
           </a:p>
           <a:p>
             <a:pPr>
               <a:defRPr sz="1400">
                 <a:solidFill>
-                  <a:srgbClr val="D9383A"/>
+                  <a:srgbClr val="2E7D32"/>
                 </a:solidFill>
               </a:defRPr>
             </a:pPr>
             <a:r>
-              <a:t>  Report A (DayViol=V): Violation</a:t>
-            </a:r>
-          </a:p>
-          <a:p>
-            <a:pPr>
-              <a:defRPr sz="1200">
-                <a:solidFill>
-                  <a:srgbClr val="D9383A"/>
-                </a:solidFill>
-              </a:defRPr>
-            </a:pPr>
-            <a:r>
-              <a:t>    ⚠ Threshold4: 13 (limit: 50)</a:t>
+              <a:t>  Report A (DayViol=?): ?</a:t>
             </a:r>
           </a:p>
           <a:p>
@@ -5462,7 +5270,7 @@
               </a:defRPr>
             </a:pPr>
             <a:r>
-              <a:t>  Report B (MonthViol=N): Pass</a:t>
+              <a:t>  Report B (MonthViol=?): ?</a:t>
             </a:r>
           </a:p>
           <a:p>
@@ -5474,7 +5282,7 @@
               </a:defRPr>
             </a:pPr>
             <a:r>
-              <a:t>Run 25 (20260623):</a:t>
+              <a:t>Run 14 (20260612):</a:t>
             </a:r>
           </a:p>
           <a:p>
@@ -5486,31 +5294,19 @@
               </a:defRPr>
             </a:pPr>
             <a:r>
-              <a:t>  Report A (DayViol=N): Pass</a:t>
+              <a:t>  Report A (DayViol=?): ?</a:t>
             </a:r>
           </a:p>
           <a:p>
             <a:pPr>
               <a:defRPr sz="1400">
                 <a:solidFill>
-                  <a:srgbClr val="D9383A"/>
+                  <a:srgbClr val="2E7D32"/>
                 </a:solidFill>
               </a:defRPr>
             </a:pPr>
             <a:r>
-              <a:t>  Report B (MonthViol=V): Violation</a:t>
-            </a:r>
-          </a:p>
-          <a:p>
-            <a:pPr>
-              <a:defRPr sz="1200">
-                <a:solidFill>
-                  <a:srgbClr val="D9383A"/>
-                </a:solidFill>
-              </a:defRPr>
-            </a:pPr>
-            <a:r>
-              <a:t>    ⚠ Threshold1: 21 (limit: 50)</a:t>
+              <a:t>  Report B (MonthViol=?): ?</a:t>
             </a:r>
           </a:p>
           <a:p>
@@ -5522,31 +5318,19 @@
               </a:defRPr>
             </a:pPr>
             <a:r>
-              <a:t>Run 6 (20260604):</a:t>
+              <a:t>Run 15 (20260613):</a:t>
             </a:r>
           </a:p>
           <a:p>
             <a:pPr>
               <a:defRPr sz="1400">
                 <a:solidFill>
-                  <a:srgbClr val="D9383A"/>
+                  <a:srgbClr val="2E7D32"/>
                 </a:solidFill>
               </a:defRPr>
             </a:pPr>
             <a:r>
-              <a:t>  Report A (DayViol=V): Violation</a:t>
-            </a:r>
-          </a:p>
-          <a:p>
-            <a:pPr>
-              <a:defRPr sz="1200">
-                <a:solidFill>
-                  <a:srgbClr val="D9383A"/>
-                </a:solidFill>
-              </a:defRPr>
-            </a:pPr>
-            <a:r>
-              <a:t>    ⚠ Threshold4: 33 (limit: 50)</a:t>
+              <a:t>  Report A (DayViol=?): ?</a:t>
             </a:r>
           </a:p>
           <a:p>
@@ -5558,7 +5342,7 @@
               </a:defRPr>
             </a:pPr>
             <a:r>
-              <a:t>  Report B (MonthViol=N): Pass</a:t>
+              <a:t>  Report B (MonthViol=?): ?</a:t>
             </a:r>
           </a:p>
           <a:p>
@@ -5570,55 +5354,31 @@
               </a:defRPr>
             </a:pPr>
             <a:r>
-              <a:t>Run 7 (20260605):</a:t>
+              <a:t>Run 16 (20260614):</a:t>
             </a:r>
           </a:p>
           <a:p>
             <a:pPr>
               <a:defRPr sz="1400">
                 <a:solidFill>
-                  <a:srgbClr val="D9383A"/>
+                  <a:srgbClr val="2E7D32"/>
                 </a:solidFill>
               </a:defRPr>
             </a:pPr>
             <a:r>
-              <a:t>  Report A (DayViol=V): Violation</a:t>
-            </a:r>
-          </a:p>
-          <a:p>
-            <a:pPr>
-              <a:defRPr sz="1200">
-                <a:solidFill>
-                  <a:srgbClr val="D9383A"/>
-                </a:solidFill>
-              </a:defRPr>
-            </a:pPr>
-            <a:r>
-              <a:t>    ⚠ Threshold2: 20 (limit: 50)</a:t>
+              <a:t>  Report A (DayViol=?): ?</a:t>
             </a:r>
           </a:p>
           <a:p>
             <a:pPr>
               <a:defRPr sz="1400">
                 <a:solidFill>
-                  <a:srgbClr val="D9383A"/>
+                  <a:srgbClr val="2E7D32"/>
                 </a:solidFill>
               </a:defRPr>
             </a:pPr>
             <a:r>
-              <a:t>  Report B (MonthViol=V): Violation</a:t>
-            </a:r>
-          </a:p>
-          <a:p>
-            <a:pPr>
-              <a:defRPr sz="1200">
-                <a:solidFill>
-                  <a:srgbClr val="D9383A"/>
-                </a:solidFill>
-              </a:defRPr>
-            </a:pPr>
-            <a:r>
-              <a:t>    ⚠ Threshold2: 30 (limit: 50)</a:t>
+              <a:t>  Report B (MonthViol=?): ?</a:t>
             </a:r>
           </a:p>
         </p:txBody>
@@ -5704,7 +5464,7 @@
               </a:defRPr>
             </a:pPr>
             <a:r>
-              <a:t>Successful completions: 20 (66.7%)</a:t>
+              <a:t>Successful completions: 2 (6.7%)</a:t>
             </a:r>
           </a:p>
           <a:p>
@@ -5716,7 +5476,7 @@
               </a:defRPr>
             </a:pPr>
             <a:r>
-              <a:t>Escalations triggered: 10 (33.3%)</a:t>
+              <a:t>Escalations triggered: 28 (93.3%)</a:t>
             </a:r>
           </a:p>
           <a:p>

</xml_diff>